<commit_message>
Add Hello World of Sensai Apps how-to article, category index, and icon
</commit_message>
<xml_diff>
--- a/Images/home.pptx
+++ b/Images/home.pptx
@@ -261,7 +261,7 @@
           <a:p>
             <a:fld id="{91D76746-8A61-41AA-94D9-AB80B57EEF87}" type="datetimeFigureOut">
               <a:rPr lang="LID4096" smtClean="0"/>
-              <a:t>08/08/2025</a:t>
+              <a:t>09/10/2026</a:t>
             </a:fld>
             <a:endParaRPr lang="LID4096"/>
           </a:p>
@@ -461,7 +461,7 @@
           <a:p>
             <a:fld id="{91D76746-8A61-41AA-94D9-AB80B57EEF87}" type="datetimeFigureOut">
               <a:rPr lang="LID4096" smtClean="0"/>
-              <a:t>08/08/2025</a:t>
+              <a:t>09/10/2026</a:t>
             </a:fld>
             <a:endParaRPr lang="LID4096"/>
           </a:p>
@@ -671,7 +671,7 @@
           <a:p>
             <a:fld id="{91D76746-8A61-41AA-94D9-AB80B57EEF87}" type="datetimeFigureOut">
               <a:rPr lang="LID4096" smtClean="0"/>
-              <a:t>08/08/2025</a:t>
+              <a:t>09/10/2026</a:t>
             </a:fld>
             <a:endParaRPr lang="LID4096"/>
           </a:p>
@@ -871,7 +871,7 @@
           <a:p>
             <a:fld id="{91D76746-8A61-41AA-94D9-AB80B57EEF87}" type="datetimeFigureOut">
               <a:rPr lang="LID4096" smtClean="0"/>
-              <a:t>08/08/2025</a:t>
+              <a:t>09/10/2026</a:t>
             </a:fld>
             <a:endParaRPr lang="LID4096"/>
           </a:p>
@@ -1147,7 +1147,7 @@
           <a:p>
             <a:fld id="{91D76746-8A61-41AA-94D9-AB80B57EEF87}" type="datetimeFigureOut">
               <a:rPr lang="LID4096" smtClean="0"/>
-              <a:t>08/08/2025</a:t>
+              <a:t>09/10/2026</a:t>
             </a:fld>
             <a:endParaRPr lang="LID4096"/>
           </a:p>
@@ -1415,7 +1415,7 @@
           <a:p>
             <a:fld id="{91D76746-8A61-41AA-94D9-AB80B57EEF87}" type="datetimeFigureOut">
               <a:rPr lang="LID4096" smtClean="0"/>
-              <a:t>08/08/2025</a:t>
+              <a:t>09/10/2026</a:t>
             </a:fld>
             <a:endParaRPr lang="LID4096"/>
           </a:p>
@@ -1830,7 +1830,7 @@
           <a:p>
             <a:fld id="{91D76746-8A61-41AA-94D9-AB80B57EEF87}" type="datetimeFigureOut">
               <a:rPr lang="LID4096" smtClean="0"/>
-              <a:t>08/08/2025</a:t>
+              <a:t>09/10/2026</a:t>
             </a:fld>
             <a:endParaRPr lang="LID4096"/>
           </a:p>
@@ -1972,7 +1972,7 @@
           <a:p>
             <a:fld id="{91D76746-8A61-41AA-94D9-AB80B57EEF87}" type="datetimeFigureOut">
               <a:rPr lang="LID4096" smtClean="0"/>
-              <a:t>08/08/2025</a:t>
+              <a:t>09/10/2026</a:t>
             </a:fld>
             <a:endParaRPr lang="LID4096"/>
           </a:p>
@@ -2085,7 +2085,7 @@
           <a:p>
             <a:fld id="{91D76746-8A61-41AA-94D9-AB80B57EEF87}" type="datetimeFigureOut">
               <a:rPr lang="LID4096" smtClean="0"/>
-              <a:t>08/08/2025</a:t>
+              <a:t>09/10/2026</a:t>
             </a:fld>
             <a:endParaRPr lang="LID4096"/>
           </a:p>
@@ -2398,7 +2398,7 @@
           <a:p>
             <a:fld id="{91D76746-8A61-41AA-94D9-AB80B57EEF87}" type="datetimeFigureOut">
               <a:rPr lang="LID4096" smtClean="0"/>
-              <a:t>08/08/2025</a:t>
+              <a:t>09/10/2026</a:t>
             </a:fld>
             <a:endParaRPr lang="LID4096"/>
           </a:p>
@@ -2687,7 +2687,7 @@
           <a:p>
             <a:fld id="{91D76746-8A61-41AA-94D9-AB80B57EEF87}" type="datetimeFigureOut">
               <a:rPr lang="LID4096" smtClean="0"/>
-              <a:t>08/08/2025</a:t>
+              <a:t>09/10/2026</a:t>
             </a:fld>
             <a:endParaRPr lang="LID4096"/>
           </a:p>
@@ -2930,7 +2930,7 @@
           <a:p>
             <a:fld id="{91D76746-8A61-41AA-94D9-AB80B57EEF87}" type="datetimeFigureOut">
               <a:rPr lang="LID4096" smtClean="0"/>
-              <a:t>08/08/2025</a:t>
+              <a:t>09/10/2026</a:t>
             </a:fld>
             <a:endParaRPr lang="LID4096"/>
           </a:p>
@@ -3898,6 +3898,94 @@
         <p:spPr>
           <a:xfrm>
             <a:off x="1254362" y="2288061"/>
+            <a:ext cx="720000" cy="720000"/>
+          </a:xfrm>
+          <a:prstGeom prst="rect">
+            <a:avLst/>
+          </a:prstGeom>
+        </p:spPr>
+      </p:pic>
+      <p:sp>
+        <p:nvSpPr>
+          <p:cNvPr id="4" name="Rectangle 3">
+            <a:extLst>
+              <a:ext uri="{FF2B5EF4-FFF2-40B4-BE49-F238E27FC236}">
+                <a16:creationId xmlns:a16="http://schemas.microsoft.com/office/drawing/2014/main" id="{20E1D9FF-43C1-0370-5C1E-820943F2122D}"/>
+              </a:ext>
+            </a:extLst>
+          </p:cNvPr>
+          <p:cNvSpPr/>
+          <p:nvPr/>
+        </p:nvSpPr>
+        <p:spPr>
+          <a:xfrm>
+            <a:off x="398439" y="3385137"/>
+            <a:ext cx="2431847" cy="1080000"/>
+          </a:xfrm>
+          <a:prstGeom prst="rect">
+            <a:avLst/>
+          </a:prstGeom>
+          <a:noFill/>
+          <a:ln>
+            <a:solidFill>
+              <a:srgbClr val="FCFCFC"/>
+            </a:solidFill>
+          </a:ln>
+        </p:spPr>
+        <p:style>
+          <a:lnRef idx="2">
+            <a:schemeClr val="accent1">
+              <a:shade val="15000"/>
+            </a:schemeClr>
+          </a:lnRef>
+          <a:fillRef idx="1">
+            <a:schemeClr val="accent1"/>
+          </a:fillRef>
+          <a:effectRef idx="0">
+            <a:schemeClr val="accent1"/>
+          </a:effectRef>
+          <a:fontRef idx="minor">
+            <a:schemeClr val="lt1"/>
+          </a:fontRef>
+        </p:style>
+        <p:txBody>
+          <a:bodyPr rtlCol="0" anchor="ctr"/>
+          <a:lstStyle/>
+          <a:p>
+            <a:pPr algn="ctr"/>
+            <a:endParaRPr lang="LID4096"/>
+          </a:p>
+        </p:txBody>
+      </p:sp>
+      <p:pic>
+        <p:nvPicPr>
+          <p:cNvPr id="11" name="Picture 10">
+            <a:extLst>
+              <a:ext uri="{FF2B5EF4-FFF2-40B4-BE49-F238E27FC236}">
+                <a16:creationId xmlns:a16="http://schemas.microsoft.com/office/drawing/2014/main" id="{B843F243-46D1-E2BC-7A51-CD53A549020A}"/>
+              </a:ext>
+            </a:extLst>
+          </p:cNvPr>
+          <p:cNvPicPr>
+            <a:picLocks noChangeAspect="1"/>
+          </p:cNvPicPr>
+          <p:nvPr/>
+        </p:nvPicPr>
+        <p:blipFill>
+          <a:blip r:embed="rId9">
+            <a:extLst>
+              <a:ext uri="{28A0092B-C50C-407E-A947-70E740481C1C}">
+                <a14:useLocalDpi xmlns:a14="http://schemas.microsoft.com/office/drawing/2010/main" val="0"/>
+              </a:ext>
+            </a:extLst>
+          </a:blip>
+          <a:stretch>
+            <a:fillRect/>
+          </a:stretch>
+        </p:blipFill>
+        <p:spPr>
+          <a:xfrm>
+            <a:off x="1254362" y="3565137"/>
             <a:ext cx="720000" cy="720000"/>
           </a:xfrm>
           <a:prstGeom prst="rect">

</xml_diff>